<commit_message>
Mise en jour du menu burger et de la navigation responsive
</commit_message>
<xml_diff>
--- a/public/docs/slides_presentation_knowledge_learning.pptx
+++ b/public/docs/slides_presentation_knowledge_learning.pptx
@@ -2884,7 +2884,7 @@
           <a:p>
             <a:fld id="{5BCAD085-E8A6-8845-BD4E-CB4CCA059FC4}" type="datetimeFigureOut">
               <a:rPr lang="en-US" smtClean="0"/>
-              <a:t>11/28/2025</a:t>
+              <a:t>3/7/2026</a:t>
             </a:fld>
             <a:endParaRPr lang="en-US"/>
           </a:p>
@@ -3050,7 +3050,7 @@
           <a:p>
             <a:fld id="{5BCAD085-E8A6-8845-BD4E-CB4CCA059FC4}" type="datetimeFigureOut">
               <a:rPr lang="en-US" smtClean="0"/>
-              <a:t>11/28/2025</a:t>
+              <a:t>3/7/2026</a:t>
             </a:fld>
             <a:endParaRPr lang="en-US"/>
           </a:p>
@@ -3226,7 +3226,7 @@
           <a:p>
             <a:fld id="{5BCAD085-E8A6-8845-BD4E-CB4CCA059FC4}" type="datetimeFigureOut">
               <a:rPr lang="en-US" smtClean="0"/>
-              <a:t>11/28/2025</a:t>
+              <a:t>3/7/2026</a:t>
             </a:fld>
             <a:endParaRPr lang="en-US"/>
           </a:p>
@@ -3392,7 +3392,7 @@
           <a:p>
             <a:fld id="{5BCAD085-E8A6-8845-BD4E-CB4CCA059FC4}" type="datetimeFigureOut">
               <a:rPr lang="en-US" smtClean="0"/>
-              <a:t>11/28/2025</a:t>
+              <a:t>3/7/2026</a:t>
             </a:fld>
             <a:endParaRPr lang="en-US"/>
           </a:p>
@@ -3634,7 +3634,7 @@
           <a:p>
             <a:fld id="{5BCAD085-E8A6-8845-BD4E-CB4CCA059FC4}" type="datetimeFigureOut">
               <a:rPr lang="en-US" smtClean="0"/>
-              <a:t>11/28/2025</a:t>
+              <a:t>3/7/2026</a:t>
             </a:fld>
             <a:endParaRPr lang="en-US"/>
           </a:p>
@@ -3918,7 +3918,7 @@
           <a:p>
             <a:fld id="{5BCAD085-E8A6-8845-BD4E-CB4CCA059FC4}" type="datetimeFigureOut">
               <a:rPr lang="en-US" smtClean="0"/>
-              <a:t>11/28/2025</a:t>
+              <a:t>3/7/2026</a:t>
             </a:fld>
             <a:endParaRPr lang="en-US"/>
           </a:p>
@@ -4332,7 +4332,7 @@
           <a:p>
             <a:fld id="{5BCAD085-E8A6-8845-BD4E-CB4CCA059FC4}" type="datetimeFigureOut">
               <a:rPr lang="en-US" smtClean="0"/>
-              <a:t>11/28/2025</a:t>
+              <a:t>3/7/2026</a:t>
             </a:fld>
             <a:endParaRPr lang="en-US"/>
           </a:p>
@@ -4446,7 +4446,7 @@
           <a:p>
             <a:fld id="{5BCAD085-E8A6-8845-BD4E-CB4CCA059FC4}" type="datetimeFigureOut">
               <a:rPr lang="en-US" smtClean="0"/>
-              <a:t>11/28/2025</a:t>
+              <a:t>3/7/2026</a:t>
             </a:fld>
             <a:endParaRPr lang="en-US"/>
           </a:p>
@@ -4537,7 +4537,7 @@
           <a:p>
             <a:fld id="{5BCAD085-E8A6-8845-BD4E-CB4CCA059FC4}" type="datetimeFigureOut">
               <a:rPr lang="en-US" smtClean="0"/>
-              <a:t>11/28/2025</a:t>
+              <a:t>3/7/2026</a:t>
             </a:fld>
             <a:endParaRPr lang="en-US"/>
           </a:p>
@@ -4810,7 +4810,7 @@
           <a:p>
             <a:fld id="{5BCAD085-E8A6-8845-BD4E-CB4CCA059FC4}" type="datetimeFigureOut">
               <a:rPr lang="en-US" smtClean="0"/>
-              <a:t>11/28/2025</a:t>
+              <a:t>3/7/2026</a:t>
             </a:fld>
             <a:endParaRPr lang="en-US"/>
           </a:p>
@@ -5060,7 +5060,7 @@
           <a:p>
             <a:fld id="{5BCAD085-E8A6-8845-BD4E-CB4CCA059FC4}" type="datetimeFigureOut">
               <a:rPr lang="en-US" smtClean="0"/>
-              <a:t>11/28/2025</a:t>
+              <a:t>3/7/2026</a:t>
             </a:fld>
             <a:endParaRPr lang="en-US"/>
           </a:p>
@@ -5275,7 +5275,7 @@
           <a:p>
             <a:fld id="{5BCAD085-E8A6-8845-BD4E-CB4CCA059FC4}" type="datetimeFigureOut">
               <a:rPr lang="en-US" smtClean="0"/>
-              <a:t>11/28/2025</a:t>
+              <a:t>3/7/2026</a:t>
             </a:fld>
             <a:endParaRPr lang="en-US"/>
           </a:p>
@@ -5897,7 +5897,7 @@
           <a:p>
             <a:r>
               <a:rPr lang="fr-FR" sz="3600"/>
-              <a:t>CONCEPTION DU MCD</a:t>
+              <a:t>CONCEPTION DU MLD</a:t>
             </a:r>
             <a:r>
               <a:rPr lang="fr-FR" sz="4000"/>

</xml_diff>